<commit_message>
Update phase1 - Marketing Analytics Business Case.pptx
</commit_message>
<xml_diff>
--- a/phase1 - Marketing Analytics Business Case.pptx
+++ b/phase1 - Marketing Analytics Business Case.pptx
@@ -468,7 +468,7 @@
           <a:p>
             <a:fld id="{1E4130FF-60BC-4C0C-AEE3-7285F2A694C4}" type="datetimeFigureOut">
               <a:rPr lang="nb-NO" smtClean="0"/>
-              <a:t>04.08.2024</a:t>
+              <a:t>28.06.2026</a:t>
             </a:fld>
             <a:endParaRPr lang="nb-NO"/>
           </a:p>
@@ -668,7 +668,7 @@
           <a:p>
             <a:fld id="{1E4130FF-60BC-4C0C-AEE3-7285F2A694C4}" type="datetimeFigureOut">
               <a:rPr lang="nb-NO" smtClean="0"/>
-              <a:t>04.08.2024</a:t>
+              <a:t>28.06.2026</a:t>
             </a:fld>
             <a:endParaRPr lang="nb-NO"/>
           </a:p>
@@ -878,7 +878,7 @@
           <a:p>
             <a:fld id="{1E4130FF-60BC-4C0C-AEE3-7285F2A694C4}" type="datetimeFigureOut">
               <a:rPr lang="nb-NO" smtClean="0"/>
-              <a:t>04.08.2024</a:t>
+              <a:t>28.06.2026</a:t>
             </a:fld>
             <a:endParaRPr lang="nb-NO"/>
           </a:p>
@@ -1078,7 +1078,7 @@
           <a:p>
             <a:fld id="{1E4130FF-60BC-4C0C-AEE3-7285F2A694C4}" type="datetimeFigureOut">
               <a:rPr lang="nb-NO" smtClean="0"/>
-              <a:t>04.08.2024</a:t>
+              <a:t>28.06.2026</a:t>
             </a:fld>
             <a:endParaRPr lang="nb-NO"/>
           </a:p>
@@ -1354,7 +1354,7 @@
           <a:p>
             <a:fld id="{1E4130FF-60BC-4C0C-AEE3-7285F2A694C4}" type="datetimeFigureOut">
               <a:rPr lang="nb-NO" smtClean="0"/>
-              <a:t>04.08.2024</a:t>
+              <a:t>28.06.2026</a:t>
             </a:fld>
             <a:endParaRPr lang="nb-NO"/>
           </a:p>
@@ -1622,7 +1622,7 @@
           <a:p>
             <a:fld id="{1E4130FF-60BC-4C0C-AEE3-7285F2A694C4}" type="datetimeFigureOut">
               <a:rPr lang="nb-NO" smtClean="0"/>
-              <a:t>04.08.2024</a:t>
+              <a:t>28.06.2026</a:t>
             </a:fld>
             <a:endParaRPr lang="nb-NO"/>
           </a:p>
@@ -2037,7 +2037,7 @@
           <a:p>
             <a:fld id="{1E4130FF-60BC-4C0C-AEE3-7285F2A694C4}" type="datetimeFigureOut">
               <a:rPr lang="nb-NO" smtClean="0"/>
-              <a:t>04.08.2024</a:t>
+              <a:t>28.06.2026</a:t>
             </a:fld>
             <a:endParaRPr lang="nb-NO"/>
           </a:p>
@@ -2179,7 +2179,7 @@
           <a:p>
             <a:fld id="{1E4130FF-60BC-4C0C-AEE3-7285F2A694C4}" type="datetimeFigureOut">
               <a:rPr lang="nb-NO" smtClean="0"/>
-              <a:t>04.08.2024</a:t>
+              <a:t>28.06.2026</a:t>
             </a:fld>
             <a:endParaRPr lang="nb-NO"/>
           </a:p>
@@ -2292,7 +2292,7 @@
           <a:p>
             <a:fld id="{1E4130FF-60BC-4C0C-AEE3-7285F2A694C4}" type="datetimeFigureOut">
               <a:rPr lang="nb-NO" smtClean="0"/>
-              <a:t>04.08.2024</a:t>
+              <a:t>28.06.2026</a:t>
             </a:fld>
             <a:endParaRPr lang="nb-NO"/>
           </a:p>
@@ -2605,7 +2605,7 @@
           <a:p>
             <a:fld id="{1E4130FF-60BC-4C0C-AEE3-7285F2A694C4}" type="datetimeFigureOut">
               <a:rPr lang="nb-NO" smtClean="0"/>
-              <a:t>04.08.2024</a:t>
+              <a:t>28.06.2026</a:t>
             </a:fld>
             <a:endParaRPr lang="nb-NO"/>
           </a:p>
@@ -2894,7 +2894,7 @@
           <a:p>
             <a:fld id="{1E4130FF-60BC-4C0C-AEE3-7285F2A694C4}" type="datetimeFigureOut">
               <a:rPr lang="nb-NO" smtClean="0"/>
-              <a:t>04.08.2024</a:t>
+              <a:t>28.06.2026</a:t>
             </a:fld>
             <a:endParaRPr lang="nb-NO"/>
           </a:p>
@@ -3137,7 +3137,7 @@
           <a:p>
             <a:fld id="{1E4130FF-60BC-4C0C-AEE3-7285F2A694C4}" type="datetimeFigureOut">
               <a:rPr lang="nb-NO" smtClean="0"/>
-              <a:t>04.08.2024</a:t>
+              <a:t>28.06.2026</a:t>
             </a:fld>
             <a:endParaRPr lang="nb-NO"/>
           </a:p>
@@ -3605,9 +3605,10 @@
           <a:lstStyle/>
           <a:p>
             <a:r>
-              <a:rPr lang="nb-NO"/>
-              <a:t>Ali Ahmad</a:t>
-            </a:r>
+              <a:rPr lang="en-DE"/>
+              <a:t>Dharmik Dave</a:t>
+            </a:r>
+            <a:endParaRPr lang="nb-NO"/>
           </a:p>
           <a:p>
             <a:endParaRPr lang="nb-NO" dirty="0"/>

</xml_diff>